<commit_message>
Briefing deck: add double-check notes to slide 3
Co-Authored-By: Claude Sonnet 5.5 <noreply@anthropic.com>
Claude-Session: https://claude.ai/code/session_01P8BAfH4LDpsPeScU2ujdPQ
</commit_message>
<xml_diff>
--- a/docs/briefing/huochai-briefing.pptx
+++ b/docs/briefing/huochai-briefing.pptx
@@ -121,13 +121,13 @@
   <p:extLst>
     <p:ext uri="{521415D9-36F7-43E2-AB2F-B90AF26B5E84}">
       <p14:sectionLst xmlns:p14="http://schemas.microsoft.com/office/powerpoint/2010/main">
-        <p14:section name="開場" id="{768dc3d8-b964-953a-2a8f-d895e74d34b2}">
+        <p14:section name="開場" id="{1d4c95a8-7f9c-b788-d869-0b50b16471df}">
           <p14:sldIdLst>
             <p14:sldId id="256"/>
             <p14:sldId id="257"/>
           </p14:sldIdLst>
         </p14:section>
-        <p14:section name="邀約怎麼運作" id="{8f903521-ded6-517d-757f-04cc46faa325}">
+        <p14:section name="邀約怎麼運作" id="{e71e55e5-e4eb-2dd5-ad23-272ae8d6f226}">
           <p14:sldIdLst>
             <p14:sldId id="258"/>
             <p14:sldId id="259"/>
@@ -137,21 +137,21 @@
             <p14:sldId id="263"/>
           </p14:sldIdLst>
         </p14:section>
-        <p14:section name="火柴與系統的默契" id="{ba231a1b-8678-0c93-cb29-a1d09b1630c4}">
+        <p14:section name="火柴與系統的默契" id="{f43dff29-bbbb-18a3-c67c-874b64e4a700}">
           <p14:sldIdLst>
             <p14:sldId id="264"/>
             <p14:sldId id="265"/>
             <p14:sldId id="266"/>
           </p14:sldIdLst>
         </p14:section>
-        <p14:section name="取消、通知與看得到什麼" id="{3515bce9-cd1f-8f1f-333d-c55e3454f566}">
+        <p14:section name="取消、通知與看得到什麼" id="{44bd3afe-e5ab-2637-85ae-2c8e36b98a3f}">
           <p14:sldIdLst>
             <p14:sldId id="267"/>
             <p14:sldId id="268"/>
             <p14:sldId id="269"/>
           </p14:sldIdLst>
         </p14:section>
-        <p14:section name="結尾" id="{c223c021-5c08-879e-d25f-732554c459b9}">
+        <p14:section name="結尾" id="{8b96b85f-b7eb-1d65-8659-24703ae0b27e}">
           <p14:sldIdLst>
             <p14:sldId id="270"/>
           </p14:sldIdLst>
@@ -1275,7 +1275,12 @@
               <a:t>這是最重要的一個觀念：月曆上的數字是「估價參考」，不是邀約的門票。
 沒空的人可能只是休假、手機看得到；你的邀約有可能讓對方重新安排。
 野放才是真的回不了訊息，所以才有倒數延後。
-唯一硬擋的是「同一天已經確認別的班」，避免兩根火柴搶同一個人。</a:t>
+唯一硬擋的是「同一天已經確認別的班」，避免兩根火柴搶同一個人。
+【二次確認】邀請本身就是一次確認：
+・願意為你調整行程的人，按「確認出班」就算數。
+・其實已經有事、只是班表沒改的人，按「婉拒」就好，不用理由，系統馬上邀下一位。月曆標有空但實際有事的落差，也會在這時被挖出來。
+・分清楚兩種「已經有事」：事情已記在 App（確認別的班、或我也出班）→ 對方顯示灰色，選不了，硬確認也會被擋；事情在 App 外面（私人安排、LINE 談了沒記）→ App 看不到，靠對方收到邀請後按婉拒來確認。
+・對方一直不回也不會卡住：倒數結束後系統同時多問下一位，她之後仍可確認，先確認的先拿到。</a:t>
             </a:r>
             <a:endParaRPr lang="en-US" dirty="0"/>
           </a:p>

</xml_diff>

<commit_message>
Briefing deck: explain in-app vs out-of-app busy on countdown slide
Co-Authored-By: Claude Sonnet 5.5 <noreply@anthropic.com>
Claude-Session: https://claude.ai/code/session_01P8BAfH4LDpsPeScU2ujdPQ
</commit_message>
<xml_diff>
--- a/docs/briefing/huochai-briefing.pptx
+++ b/docs/briefing/huochai-briefing.pptx
@@ -121,13 +121,13 @@
   <p:extLst>
     <p:ext uri="{521415D9-36F7-43E2-AB2F-B90AF26B5E84}">
       <p14:sectionLst xmlns:p14="http://schemas.microsoft.com/office/powerpoint/2010/main">
-        <p14:section name="開場" id="{1d4c95a8-7f9c-b788-d869-0b50b16471df}">
+        <p14:section name="開場" id="{b70051ac-4d8a-6954-b065-60825f11e072}">
           <p14:sldIdLst>
             <p14:sldId id="256"/>
             <p14:sldId id="257"/>
           </p14:sldIdLst>
         </p14:section>
-        <p14:section name="邀約怎麼運作" id="{e71e55e5-e4eb-2dd5-ad23-272ae8d6f226}">
+        <p14:section name="邀約怎麼運作" id="{cf7e7527-e5be-580e-efa5-a4a3bdd8c035}">
           <p14:sldIdLst>
             <p14:sldId id="258"/>
             <p14:sldId id="259"/>
@@ -137,21 +137,21 @@
             <p14:sldId id="263"/>
           </p14:sldIdLst>
         </p14:section>
-        <p14:section name="火柴與系統的默契" id="{f43dff29-bbbb-18a3-c67c-874b64e4a700}">
+        <p14:section name="火柴與系統的默契" id="{678bc902-8a39-ce41-845f-906675292e11}">
           <p14:sldIdLst>
             <p14:sldId id="264"/>
             <p14:sldId id="265"/>
             <p14:sldId id="266"/>
           </p14:sldIdLst>
         </p14:section>
-        <p14:section name="取消、通知與看得到什麼" id="{44bd3afe-e5ab-2637-85ae-2c8e36b98a3f}">
+        <p14:section name="取消、通知與看得到什麼" id="{8a6dc942-308b-cd6b-fda7-40f934d82f62}">
           <p14:sldIdLst>
             <p14:sldId id="267"/>
             <p14:sldId id="268"/>
             <p14:sldId id="269"/>
           </p14:sldIdLst>
         </p14:section>
-        <p14:section name="結尾" id="{8b96b85f-b7eb-1d65-8659-24703ae0b27e}">
+        <p14:section name="結尾" id="{5d984fad-772d-b7f6-7953-7e1c91a6c419}">
           <p14:sldIdLst>
             <p14:sldId id="270"/>
           </p14:sldIdLst>
@@ -1730,7 +1730,11 @@
             <a:r>
               <a:rPr lang="en-US" dirty="0"/>
               <a:t>倒數是「活躍時間」：晚上 22:00 到早上 08:00 不扣。
-野放的人邀請時，若在 18:00 前收到，倒數從 18:00 才開始，不會因為在忙而錯過。
+「在忙」有兩種，用 App 之內／之外來講最好懂：
+・出班中＝事情在 App 之內。系統從她已確認的班自動判斷，不用她標。
+・野放＝事情在 App 之外（在別處工作、出去玩、不太能看手機）。她自己在月曆標的，邀請她的火柴看得到，其他夥伴看到的是「沒空」。
+兩種都一樣：邀請在當天 18:00 前送到，倒數從 18:00 才開始，不會因為在忙而錯過。
+注意別混淆：這裡的「出班中」是她收到邀請的『當天』有班；如果是『要排的那一天』她已有班，她會顯示灰色、選不了，是另一回事。
 急件會用比較多 LINE 訊息，後面會講。</a:t>
             </a:r>
             <a:endParaRPr lang="en-US" dirty="0"/>
@@ -10875,8 +10879,8 @@
         </p:nvSpPr>
         <p:spPr>
           <a:xfrm>
-            <a:off x="5349240" y="1234440"/>
-            <a:ext cx="3337560" cy="640080"/>
+            <a:off x="5349240" y="1170432"/>
+            <a:ext cx="3337560" cy="731520"/>
           </a:xfrm>
           <a:prstGeom prst="rect">
             <a:avLst/>
@@ -10960,8 +10964,8 @@
         </p:nvSpPr>
         <p:spPr>
           <a:xfrm>
-            <a:off x="5349240" y="2103120"/>
-            <a:ext cx="3337560" cy="640080"/>
+            <a:off x="5349240" y="2039112"/>
+            <a:ext cx="3337560" cy="731520"/>
           </a:xfrm>
           <a:prstGeom prst="rect">
             <a:avLst/>
@@ -10982,7 +10986,7 @@
                   <a:schemeClr val="tx1"/>
                 </a:solidFill>
               </a:rPr>
-              <a:t>對方當天出班或野放：到 18:00 才開始倒數</a:t>
+              <a:t>她收到邀請當天在忙：出班中（App 內）或野放（App 外），18:00 才開始倒數</a:t>
             </a:r>
             <a:endParaRPr lang="en-US" sz="1400" dirty="0"/>
           </a:p>
@@ -11045,8 +11049,8 @@
         </p:nvSpPr>
         <p:spPr>
           <a:xfrm>
-            <a:off x="5349240" y="2971800"/>
-            <a:ext cx="3337560" cy="640080"/>
+            <a:off x="5349240" y="2907792"/>
+            <a:ext cx="3337560" cy="731520"/>
           </a:xfrm>
           <a:prstGeom prst="rect">
             <a:avLst/>

</xml_diff>

<commit_message>
Briefing deck: encourage filling availability notes on slide 3
Co-Authored-By: Claude Sonnet 5.5 <noreply@anthropic.com>
Claude-Session: https://claude.ai/code/session_01P8BAfH4LDpsPeScU2ujdPQ
</commit_message>
<xml_diff>
--- a/docs/briefing/huochai-briefing.pptx
+++ b/docs/briefing/huochai-briefing.pptx
@@ -121,13 +121,13 @@
   <p:extLst>
     <p:ext uri="{521415D9-36F7-43E2-AB2F-B90AF26B5E84}">
       <p14:sectionLst xmlns:p14="http://schemas.microsoft.com/office/powerpoint/2010/main">
-        <p14:section name="開場" id="{b70051ac-4d8a-6954-b065-60825f11e072}">
+        <p14:section name="開場" id="{686e2aca-5ac9-564a-839f-b0d70241fb94}">
           <p14:sldIdLst>
             <p14:sldId id="256"/>
             <p14:sldId id="257"/>
           </p14:sldIdLst>
         </p14:section>
-        <p14:section name="邀約怎麼運作" id="{cf7e7527-e5be-580e-efa5-a4a3bdd8c035}">
+        <p14:section name="邀約怎麼運作" id="{800287ca-9b57-e586-e9a4-4e44f43052b9}">
           <p14:sldIdLst>
             <p14:sldId id="258"/>
             <p14:sldId id="259"/>
@@ -137,21 +137,21 @@
             <p14:sldId id="263"/>
           </p14:sldIdLst>
         </p14:section>
-        <p14:section name="火柴與系統的默契" id="{678bc902-8a39-ce41-845f-906675292e11}">
+        <p14:section name="火柴與系統的默契" id="{32ea052a-8d76-14d7-b209-ab0aa5debd25}">
           <p14:sldIdLst>
             <p14:sldId id="264"/>
             <p14:sldId id="265"/>
             <p14:sldId id="266"/>
           </p14:sldIdLst>
         </p14:section>
-        <p14:section name="取消、通知與看得到什麼" id="{8a6dc942-308b-cd6b-fda7-40f934d82f62}">
+        <p14:section name="取消、通知與看得到什麼" id="{243a5be2-311d-577c-2b8b-2d6a1ea5dc75}">
           <p14:sldIdLst>
             <p14:sldId id="267"/>
             <p14:sldId id="268"/>
             <p14:sldId id="269"/>
           </p14:sldIdLst>
         </p14:section>
-        <p14:section name="結尾" id="{5d984fad-772d-b7f6-7953-7e1c91a6c419}">
+        <p14:section name="結尾" id="{09dedef6-f7c1-7dac-a2be-74979f49bfed}">
           <p14:sldIdLst>
             <p14:sldId id="270"/>
           </p14:sldIdLst>
@@ -1280,7 +1280,15 @@
 ・願意為你調整行程的人，按「確認出班」就算數。
 ・其實已經有事、只是班表沒改的人，按「婉拒」就好，不用理由，系統馬上邀下一位。月曆標有空但實際有事的落差，也會在這時被挖出來。
 ・分清楚兩種「已經有事」：事情已記在 App（確認別的班、或我也出班）→ 對方顯示灰色，選不了，硬確認也會被擋；事情在 App 外面（私人安排、LINE 談了沒記）→ App 看不到，靠對方收到邀請後按婉拒來確認。
-・對方一直不回也不會卡住：倒數結束後系統同時多問下一位，她之後仍可確認，先確認的先拿到。</a:t>
+・對方一直不回也不會卡住：倒數結束後系統同時多問下一位，她之後仍可確認，先確認的先拿到。
+【不填班也收得到邀請，但還是鼓勵大家填】
+先回答最多人問的：沒填班，還是會收到邀請。因為不填通常不是不想接，是還不確定：只能確定未來一週、想看這個月已經出幾班再決定、或單純忘了。所以 App 不用「有沒有填」來擋邀請，你收到時再決定，接或婉拒都可以，婉拒不用理由。
+但是，請大家還是盡量填：
+1. 月曆上的人數才準：「還能約」只算標了有空的人。火柴估價時最怕看到有人、結果約不到；大家填得準，數字就準。
+2. 標有空的人，在火柴排順位時排在名單上方，比較容易被先想到；沒標的人在「其他成員」，要火柴特別去找。
+3. 標野放有保護：邀請當天她在別處忙，倒數等到 18:00 才開始，不會因為晚回而錯過。
+4. 不用一次填完：只能確定一週，就先填那一週，隨時可以改。每月 20 號前填下個月，也可以按「沿用上月習慣」一鍵帶入再微調。
+一句話收尾：不填，只是讓大家看不到你有空；填了，機會才會主動找上你。</a:t>
             </a:r>
             <a:endParaRPr lang="en-US" dirty="0"/>
           </a:p>

</xml_diff>

<commit_message>
Briefing deck: tighten wording of availability encouragement notes
Co-Authored-By: Claude Sonnet 5.5 <noreply@anthropic.com>
Claude-Session: https://claude.ai/code/session_01P8BAfH4LDpsPeScU2ujdPQ
</commit_message>
<xml_diff>
--- a/docs/briefing/huochai-briefing.pptx
+++ b/docs/briefing/huochai-briefing.pptx
@@ -121,13 +121,13 @@
   <p:extLst>
     <p:ext uri="{521415D9-36F7-43E2-AB2F-B90AF26B5E84}">
       <p14:sectionLst xmlns:p14="http://schemas.microsoft.com/office/powerpoint/2010/main">
-        <p14:section name="開場" id="{686e2aca-5ac9-564a-839f-b0d70241fb94}">
+        <p14:section name="開場" id="{e7c5888d-767b-e49c-22f4-ec6e67307635}">
           <p14:sldIdLst>
             <p14:sldId id="256"/>
             <p14:sldId id="257"/>
           </p14:sldIdLst>
         </p14:section>
-        <p14:section name="邀約怎麼運作" id="{800287ca-9b57-e586-e9a4-4e44f43052b9}">
+        <p14:section name="邀約怎麼運作" id="{28887fe1-eaed-1b8a-2b36-b6ed387bc4b1}">
           <p14:sldIdLst>
             <p14:sldId id="258"/>
             <p14:sldId id="259"/>
@@ -137,21 +137,21 @@
             <p14:sldId id="263"/>
           </p14:sldIdLst>
         </p14:section>
-        <p14:section name="火柴與系統的默契" id="{32ea052a-8d76-14d7-b209-ab0aa5debd25}">
+        <p14:section name="火柴與系統的默契" id="{e2e40dab-f972-41a9-fd34-212d9b150af1}">
           <p14:sldIdLst>
             <p14:sldId id="264"/>
             <p14:sldId id="265"/>
             <p14:sldId id="266"/>
           </p14:sldIdLst>
         </p14:section>
-        <p14:section name="取消、通知與看得到什麼" id="{243a5be2-311d-577c-2b8b-2d6a1ea5dc75}">
+        <p14:section name="取消、通知與看得到什麼" id="{0344d2f3-f610-b08a-d766-938c68cf5d9d}">
           <p14:sldIdLst>
             <p14:sldId id="267"/>
             <p14:sldId id="268"/>
             <p14:sldId id="269"/>
           </p14:sldIdLst>
         </p14:section>
-        <p14:section name="結尾" id="{09dedef6-f7c1-7dac-a2be-74979f49bfed}">
+        <p14:section name="結尾" id="{543bf615-14f7-77af-b7d8-4807254a1b65}">
           <p14:sldIdLst>
             <p14:sldId id="270"/>
           </p14:sldIdLst>
@@ -1281,14 +1281,15 @@
 ・其實已經有事、只是班表沒改的人，按「婉拒」就好，不用理由，系統馬上邀下一位。月曆標有空但實際有事的落差，也會在這時被挖出來。
 ・分清楚兩種「已經有事」：事情已記在 App（確認別的班、或我也出班）→ 對方顯示灰色，選不了，硬確認也會被擋；事情在 App 外面（私人安排、LINE 談了沒記）→ App 看不到，靠對方收到邀請後按婉拒來確認。
 ・對方一直不回也不會卡住：倒數結束後系統同時多問下一位，她之後仍可確認，先確認的先拿到。
-【不填班也收得到邀請，但還是鼓勵大家填】
-先回答最多人問的：沒填班，還是會收到邀請。因為不填通常不是不想接，是還不確定：只能確定未來一週、想看這個月已經出幾班再決定、或單純忘了。所以 App 不用「有沒有填」來擋邀請，你收到時再決定，接或婉拒都可以，婉拒不用理由。
-但是，請大家還是盡量填：
-1. 月曆上的人數才準：「還能約」只算標了有空的人。火柴估價時最怕看到有人、結果約不到；大家填得準，數字就準。
-2. 標有空的人，在火柴排順位時排在名單上方，比較容易被先想到；沒標的人在「其他成員」，要火柴特別去找。
-3. 標野放有保護：邀請當天她在別處忙，倒數等到 18:00 才開始，不會因為晚回而錯過。
-4. 不用一次填完：只能確定一週，就先填那一週，隨時可以改。每月 20 號前填下個月，也可以按「沿用上月習慣」一鍵帶入再微調。
-一句話收尾：不填，只是讓大家看不到你有空；填了，機會才會主動找上你。</a:t>
+【不填班也收得到邀請，但請大家盡量填】
+先回答最多人問的：沒填班，還是會收到邀請。
+不填通常不是不想接，是還不確定：只能確定未來一週、想看這個月已經出幾班再決定，或單純忘了。所以 App 不拿「有沒有填」擋邀請：你收到時再決定，接或婉拒都行，婉拒不用理由。
+那為什麼還要填？
+1. 月曆才準：「還能約」只算標了有空的人。填得準，火柴估價時才不會看到有人、結果約不到。
+2. 機會先找上你：標有空的人，在火柴排順位時排在名單上方；沒標的在「其他成員」，火柴要特地去找。
+3. 野放有保護：邀請當天你在別處忙，倒數等到 18:00 才開始，不怕晚回就錯過。
+4. 填起來不難：只能確定一週，就先填一週，隨時可改；每月 20 號前填下個月，也可按「沿用上月習慣」一鍵帶入。
+收尾一句：不填，只是讓大家看不到你有空；填了，機會才會主動找上你。</a:t>
             </a:r>
             <a:endParaRPr lang="en-US" dirty="0"/>
           </a:p>

</xml_diff>